<commit_message>
week2 & week3 updates
</commit_message>
<xml_diff>
--- a/module-02-environments/slides/Week2_EnvMgmt_Bioinformatics.pptx
+++ b/module-02-environments/slides/Week2_EnvMgmt_Bioinformatics.pptx
@@ -9477,7 +9477,7 @@
           <a:p>
             <a:fld id="{5BCAD085-E8A6-8845-BD4E-CB4CCA059FC4}" type="datetimeFigureOut">
               <a:rPr lang="en-US" smtClean="0"/>
-              <a:t>9/29/25</a:t>
+              <a:t>9/30/25</a:t>
             </a:fld>
             <a:endParaRPr lang="en-US"/>
           </a:p>
@@ -9645,7 +9645,7 @@
           <a:p>
             <a:fld id="{5BCAD085-E8A6-8845-BD4E-CB4CCA059FC4}" type="datetimeFigureOut">
               <a:rPr lang="en-US" smtClean="0"/>
-              <a:t>9/29/25</a:t>
+              <a:t>9/30/25</a:t>
             </a:fld>
             <a:endParaRPr lang="en-US"/>
           </a:p>
@@ -9823,7 +9823,7 @@
           <a:p>
             <a:fld id="{5BCAD085-E8A6-8845-BD4E-CB4CCA059FC4}" type="datetimeFigureOut">
               <a:rPr lang="en-US" smtClean="0"/>
-              <a:t>9/29/25</a:t>
+              <a:t>9/30/25</a:t>
             </a:fld>
             <a:endParaRPr lang="en-US"/>
           </a:p>
@@ -9991,7 +9991,7 @@
           <a:p>
             <a:fld id="{5BCAD085-E8A6-8845-BD4E-CB4CCA059FC4}" type="datetimeFigureOut">
               <a:rPr lang="en-US" smtClean="0"/>
-              <a:t>9/29/25</a:t>
+              <a:t>9/30/25</a:t>
             </a:fld>
             <a:endParaRPr lang="en-US"/>
           </a:p>
@@ -10236,7 +10236,7 @@
           <a:p>
             <a:fld id="{5BCAD085-E8A6-8845-BD4E-CB4CCA059FC4}" type="datetimeFigureOut">
               <a:rPr lang="en-US" smtClean="0"/>
-              <a:t>9/29/25</a:t>
+              <a:t>9/30/25</a:t>
             </a:fld>
             <a:endParaRPr lang="en-US"/>
           </a:p>
@@ -10521,7 +10521,7 @@
           <a:p>
             <a:fld id="{5BCAD085-E8A6-8845-BD4E-CB4CCA059FC4}" type="datetimeFigureOut">
               <a:rPr lang="en-US" smtClean="0"/>
-              <a:t>9/29/25</a:t>
+              <a:t>9/30/25</a:t>
             </a:fld>
             <a:endParaRPr lang="en-US"/>
           </a:p>
@@ -10940,7 +10940,7 @@
           <a:p>
             <a:fld id="{5BCAD085-E8A6-8845-BD4E-CB4CCA059FC4}" type="datetimeFigureOut">
               <a:rPr lang="en-US" smtClean="0"/>
-              <a:t>9/29/25</a:t>
+              <a:t>9/30/25</a:t>
             </a:fld>
             <a:endParaRPr lang="en-US"/>
           </a:p>
@@ -11057,7 +11057,7 @@
           <a:p>
             <a:fld id="{5BCAD085-E8A6-8845-BD4E-CB4CCA059FC4}" type="datetimeFigureOut">
               <a:rPr lang="en-US" smtClean="0"/>
-              <a:t>9/29/25</a:t>
+              <a:t>9/30/25</a:t>
             </a:fld>
             <a:endParaRPr lang="en-US"/>
           </a:p>
@@ -11152,7 +11152,7 @@
           <a:p>
             <a:fld id="{5BCAD085-E8A6-8845-BD4E-CB4CCA059FC4}" type="datetimeFigureOut">
               <a:rPr lang="en-US" smtClean="0"/>
-              <a:t>9/29/25</a:t>
+              <a:t>9/30/25</a:t>
             </a:fld>
             <a:endParaRPr lang="en-US"/>
           </a:p>
@@ -11427,7 +11427,7 @@
           <a:p>
             <a:fld id="{5BCAD085-E8A6-8845-BD4E-CB4CCA059FC4}" type="datetimeFigureOut">
               <a:rPr lang="en-US" smtClean="0"/>
-              <a:t>9/29/25</a:t>
+              <a:t>9/30/25</a:t>
             </a:fld>
             <a:endParaRPr lang="en-US"/>
           </a:p>
@@ -11679,7 +11679,7 @@
           <a:p>
             <a:fld id="{5BCAD085-E8A6-8845-BD4E-CB4CCA059FC4}" type="datetimeFigureOut">
               <a:rPr lang="en-US" smtClean="0"/>
-              <a:t>9/29/25</a:t>
+              <a:t>9/30/25</a:t>
             </a:fld>
             <a:endParaRPr lang="en-US"/>
           </a:p>
@@ -11890,7 +11890,7 @@
           <a:p>
             <a:fld id="{5BCAD085-E8A6-8845-BD4E-CB4CCA059FC4}" type="datetimeFigureOut">
               <a:rPr lang="en-US" smtClean="0"/>
-              <a:t>9/29/25</a:t>
+              <a:t>9/30/25</a:t>
             </a:fld>
             <a:endParaRPr lang="en-US"/>
           </a:p>
@@ -14981,7 +14981,7 @@
         </p:nvSpPr>
         <p:spPr>
           <a:xfrm>
-            <a:off x="1005840" y="3291840"/>
+            <a:off x="1390850" y="3338928"/>
             <a:ext cx="10454335" cy="2062103"/>
           </a:xfrm>
           <a:prstGeom prst="rect">
@@ -15032,7 +15032,7 @@
             </a:r>
             <a:r>
               <a:rPr dirty="0"/>
-              <a:t>=0.12.* </a:t>
+              <a:t> </a:t>
             </a:r>
             <a:r>
               <a:rPr dirty="0" err="1"/>
@@ -15040,7 +15040,7 @@
             </a:r>
             <a:r>
               <a:rPr dirty="0"/>
-              <a:t>=1.* -c </a:t>
+              <a:t> -c </a:t>
             </a:r>
             <a:r>
               <a:rPr dirty="0" err="1"/>
@@ -15442,7 +15442,7 @@
         </p:nvSpPr>
         <p:spPr>
           <a:xfrm>
-            <a:off x="1289304" y="2902913"/>
+            <a:off x="1347313" y="1288428"/>
             <a:ext cx="9849751" cy="3032168"/>
           </a:xfrm>
           <a:prstGeom prst="rect">
@@ -15485,12 +15485,16 @@
               <a:rPr lang="en-US" sz="1300" dirty="0" err="1"/>
               <a:t>SAMtools</a:t>
             </a:r>
+            <a:r>
+              <a:rPr lang="en-US" sz="1300" dirty="0"/>
+              <a:t> (3 tools) </a:t>
+            </a:r>
             <a:br>
               <a:rPr lang="en-US" sz="1300" dirty="0"/>
             </a:br>
             <a:r>
               <a:rPr lang="en-US" sz="1300" dirty="0"/>
-              <a:t>mamba create -n assembly spades=3.15.* bwa=0.7.* </a:t>
+              <a:t>mamba create -n assembly spades bwa </a:t>
             </a:r>
             <a:r>
               <a:rPr lang="en-US" sz="1300" dirty="0" err="1"/>
@@ -15498,7 +15502,7 @@
             </a:r>
             <a:r>
               <a:rPr lang="en-US" sz="1300" dirty="0"/>
-              <a:t>=1.* -c </a:t>
+              <a:t> -c </a:t>
             </a:r>
             <a:r>
               <a:rPr lang="en-US" sz="1300" dirty="0" err="1"/>
@@ -15581,6 +15585,10 @@
               <a:rPr lang="en-US" sz="1300" dirty="0" err="1"/>
               <a:t>Prokka</a:t>
             </a:r>
+            <a:r>
+              <a:rPr lang="en-US" sz="1300" dirty="0"/>
+              <a:t> (tool)</a:t>
+            </a:r>
             <a:br>
               <a:rPr lang="en-US" sz="1300" dirty="0"/>
             </a:br>
@@ -15594,7 +15602,7 @@
             </a:r>
             <a:r>
               <a:rPr lang="en-US" sz="1300" dirty="0"/>
-              <a:t>=1.14.* -c </a:t>
+              <a:t> -c </a:t>
             </a:r>
             <a:r>
               <a:rPr lang="en-US" sz="1300" dirty="0" err="1"/>

</xml_diff>